<commit_message>
Restyle Minna 1 Bab 2 slides to match the approved reference
Co-Authored-By: Claude Opus 5.5 <noreply@anthropic.com>
Claude-Session: https://claude.ai/code/session_01R2r5CpV1mHfrPgo3fPN6U9
</commit_message>
<xml_diff>
--- a/Modul Minna 1/Bab 2/27. Minna 1 Tata Bahasa Bab 2 - Slide.pptx
+++ b/Modul Minna 1/Bab 2/27. Minna 1 Tata Bahasa Bab 2 - Slide.pptx
@@ -1981,7 +1981,7 @@
                 <a:ea typeface="Arial" pitchFamily="34" charset="-122"/>
                 <a:cs typeface="Arial" pitchFamily="34" charset="-120"/>
               </a:rPr>
-              <a:t>Kapan pakai これ, それ, atau あれ? Yuk belajar menunjuk benda dan menanyakan milik siapa.</a:t>
+              <a:t>"Ini", "itu", dan "itu" — kok beda-beda? Rahasianya ada di jarak.</a:t>
             </a:r>
             <a:endParaRPr lang="en-US" sz="1300" dirty="0"/>
           </a:p>
@@ -2171,12 +2171,12 @@
         </p:nvSpPr>
         <p:spPr>
           <a:xfrm>
-            <a:off x="612648" y="1517904"/>
-            <a:ext cx="3730752" cy="566928"/>
+            <a:off x="612648" y="1609344"/>
+            <a:ext cx="3730752" cy="612648"/>
           </a:xfrm>
           <a:prstGeom prst="roundRect">
             <a:avLst>
-              <a:gd name="adj" fmla="val 9677"/>
+              <a:gd name="adj" fmla="val 8955"/>
             </a:avLst>
           </a:prstGeom>
           <a:solidFill>
@@ -2205,7 +2205,7 @@
         </p:nvSpPr>
         <p:spPr>
           <a:xfrm>
-            <a:off x="740664" y="1641348"/>
+            <a:off x="740664" y="1755648"/>
             <a:ext cx="320040" cy="320040"/>
           </a:xfrm>
           <a:prstGeom prst="ellipse">
@@ -2250,8 +2250,8 @@
         </p:nvSpPr>
         <p:spPr>
           <a:xfrm>
-            <a:off x="1188720" y="1517904"/>
-            <a:ext cx="3063240" cy="566928"/>
+            <a:off x="1188720" y="1609344"/>
+            <a:ext cx="3063240" cy="612648"/>
           </a:xfrm>
           <a:prstGeom prst="rect">
             <a:avLst/>
@@ -2275,7 +2275,7 @@
                 <a:ea typeface="Arial" pitchFamily="34" charset="-122"/>
                 <a:cs typeface="Arial" pitchFamily="34" charset="-120"/>
               </a:rPr>
-              <a:t>Ini / itu</a:t>
+              <a:t>Kore/sore/are</a:t>
             </a:r>
             <a:pPr indent="0" marL="0">
               <a:buNone/>
@@ -2303,12 +2303,12 @@
         </p:nvSpPr>
         <p:spPr>
           <a:xfrm>
-            <a:off x="4800600" y="1517904"/>
-            <a:ext cx="3730752" cy="566928"/>
+            <a:off x="4800600" y="1609344"/>
+            <a:ext cx="3730752" cy="612648"/>
           </a:xfrm>
           <a:prstGeom prst="roundRect">
             <a:avLst>
-              <a:gd name="adj" fmla="val 9677"/>
+              <a:gd name="adj" fmla="val 8955"/>
             </a:avLst>
           </a:prstGeom>
           <a:solidFill>
@@ -2337,7 +2337,7 @@
         </p:nvSpPr>
         <p:spPr>
           <a:xfrm>
-            <a:off x="4928616" y="1641348"/>
+            <a:off x="4928616" y="1755648"/>
             <a:ext cx="320040" cy="320040"/>
           </a:xfrm>
           <a:prstGeom prst="ellipse">
@@ -2382,8 +2382,8 @@
         </p:nvSpPr>
         <p:spPr>
           <a:xfrm>
-            <a:off x="5376672" y="1517904"/>
-            <a:ext cx="3063240" cy="566928"/>
+            <a:off x="5376672" y="1609344"/>
+            <a:ext cx="3063240" cy="612648"/>
           </a:xfrm>
           <a:prstGeom prst="rect">
             <a:avLst/>
@@ -2407,7 +2407,7 @@
                 <a:ea typeface="Arial" pitchFamily="34" charset="-122"/>
                 <a:cs typeface="Arial" pitchFamily="34" charset="-120"/>
               </a:rPr>
-              <a:t>Ini / itu + KB</a:t>
+              <a:t>Kono/sono/ano</a:t>
             </a:r>
             <a:pPr indent="0" marL="0">
               <a:buNone/>
@@ -2435,12 +2435,12 @@
         </p:nvSpPr>
         <p:spPr>
           <a:xfrm>
-            <a:off x="612648" y="2194560"/>
-            <a:ext cx="3730752" cy="566928"/>
+            <a:off x="612648" y="2331720"/>
+            <a:ext cx="3730752" cy="612648"/>
           </a:xfrm>
           <a:prstGeom prst="roundRect">
             <a:avLst>
-              <a:gd name="adj" fmla="val 9677"/>
+              <a:gd name="adj" fmla="val 8955"/>
             </a:avLst>
           </a:prstGeom>
           <a:solidFill>
@@ -2469,7 +2469,7 @@
         </p:nvSpPr>
         <p:spPr>
           <a:xfrm>
-            <a:off x="740664" y="2318004"/>
+            <a:off x="740664" y="2478024"/>
             <a:ext cx="320040" cy="320040"/>
           </a:xfrm>
           <a:prstGeom prst="ellipse">
@@ -2514,8 +2514,8 @@
         </p:nvSpPr>
         <p:spPr>
           <a:xfrm>
-            <a:off x="1188720" y="2194560"/>
-            <a:ext cx="3063240" cy="566928"/>
+            <a:off x="1188720" y="2331720"/>
+            <a:ext cx="3063240" cy="612648"/>
           </a:xfrm>
           <a:prstGeom prst="rect">
             <a:avLst/>
@@ -2539,7 +2539,7 @@
                 <a:ea typeface="Arial" pitchFamily="34" charset="-122"/>
                 <a:cs typeface="Arial" pitchFamily="34" charset="-120"/>
               </a:rPr>
-              <a:t>Ya / bukan</a:t>
+              <a:t>Jawab ya/bukan</a:t>
             </a:r>
             <a:pPr indent="0" marL="0">
               <a:buNone/>
@@ -2567,12 +2567,12 @@
         </p:nvSpPr>
         <p:spPr>
           <a:xfrm>
-            <a:off x="4800600" y="2194560"/>
-            <a:ext cx="3730752" cy="566928"/>
+            <a:off x="4800600" y="2331720"/>
+            <a:ext cx="3730752" cy="612648"/>
           </a:xfrm>
           <a:prstGeom prst="roundRect">
             <a:avLst>
-              <a:gd name="adj" fmla="val 9677"/>
+              <a:gd name="adj" fmla="val 8955"/>
             </a:avLst>
           </a:prstGeom>
           <a:solidFill>
@@ -2601,7 +2601,7 @@
         </p:nvSpPr>
         <p:spPr>
           <a:xfrm>
-            <a:off x="4928616" y="2318004"/>
+            <a:off x="4928616" y="2478024"/>
             <a:ext cx="320040" cy="320040"/>
           </a:xfrm>
           <a:prstGeom prst="ellipse">
@@ -2646,8 +2646,8 @@
         </p:nvSpPr>
         <p:spPr>
           <a:xfrm>
-            <a:off x="5376672" y="2194560"/>
-            <a:ext cx="3063240" cy="566928"/>
+            <a:off x="5376672" y="2331720"/>
+            <a:ext cx="3063240" cy="612648"/>
           </a:xfrm>
           <a:prstGeom prst="rect">
             <a:avLst/>
@@ -2671,7 +2671,7 @@
                 <a:ea typeface="Arial" pitchFamily="34" charset="-122"/>
                 <a:cs typeface="Arial" pitchFamily="34" charset="-120"/>
               </a:rPr>
-              <a:t>A atau B?</a:t>
+              <a:t>Pilih A atau B</a:t>
             </a:r>
             <a:pPr indent="0" marL="0">
               <a:buNone/>
@@ -2685,7 +2685,7 @@
                 <a:ea typeface="Arial" pitchFamily="34" charset="-122"/>
                 <a:cs typeface="Arial" pitchFamily="34" charset="-120"/>
               </a:rPr>
-              <a:t>   ～か、～か</a:t>
+              <a:t>   か、か</a:t>
             </a:r>
             <a:endParaRPr lang="en-US" sz="1100" dirty="0"/>
           </a:p>
@@ -2699,12 +2699,12 @@
         </p:nvSpPr>
         <p:spPr>
           <a:xfrm>
-            <a:off x="612648" y="2871216"/>
-            <a:ext cx="3730752" cy="566928"/>
+            <a:off x="612648" y="3054096"/>
+            <a:ext cx="3730752" cy="612648"/>
           </a:xfrm>
           <a:prstGeom prst="roundRect">
             <a:avLst>
-              <a:gd name="adj" fmla="val 9677"/>
+              <a:gd name="adj" fmla="val 8955"/>
             </a:avLst>
           </a:prstGeom>
           <a:solidFill>
@@ -2733,7 +2733,7 @@
         </p:nvSpPr>
         <p:spPr>
           <a:xfrm>
-            <a:off x="740664" y="2994660"/>
+            <a:off x="740664" y="3200400"/>
             <a:ext cx="320040" cy="320040"/>
           </a:xfrm>
           <a:prstGeom prst="ellipse">
@@ -2778,8 +2778,8 @@
         </p:nvSpPr>
         <p:spPr>
           <a:xfrm>
-            <a:off x="1188720" y="2871216"/>
-            <a:ext cx="3063240" cy="566928"/>
+            <a:off x="1188720" y="3054096"/>
+            <a:ext cx="3063240" cy="612648"/>
           </a:xfrm>
           <a:prstGeom prst="rect">
             <a:avLst/>
@@ -2831,12 +2831,12 @@
         </p:nvSpPr>
         <p:spPr>
           <a:xfrm>
-            <a:off x="4800600" y="2871216"/>
-            <a:ext cx="3730752" cy="566928"/>
+            <a:off x="4800600" y="3054096"/>
+            <a:ext cx="3730752" cy="612648"/>
           </a:xfrm>
           <a:prstGeom prst="roundRect">
             <a:avLst>
-              <a:gd name="adj" fmla="val 9677"/>
+              <a:gd name="adj" fmla="val 8955"/>
             </a:avLst>
           </a:prstGeom>
           <a:solidFill>
@@ -2865,7 +2865,7 @@
         </p:nvSpPr>
         <p:spPr>
           <a:xfrm>
-            <a:off x="4928616" y="2994660"/>
+            <a:off x="4928616" y="3200400"/>
             <a:ext cx="320040" cy="320040"/>
           </a:xfrm>
           <a:prstGeom prst="ellipse">
@@ -2910,8 +2910,8 @@
         </p:nvSpPr>
         <p:spPr>
           <a:xfrm>
-            <a:off x="5376672" y="2871216"/>
-            <a:ext cx="3063240" cy="566928"/>
+            <a:off x="5376672" y="3054096"/>
+            <a:ext cx="3063240" cy="612648"/>
           </a:xfrm>
           <a:prstGeom prst="rect">
             <a:avLst/>
@@ -2935,7 +2935,7 @@
                 <a:ea typeface="Arial" pitchFamily="34" charset="-122"/>
                 <a:cs typeface="Arial" pitchFamily="34" charset="-120"/>
               </a:rPr>
-              <a:t>Pengganti KB</a:t>
+              <a:t>Pengganti benda</a:t>
             </a:r>
             <a:pPr indent="0" marL="0">
               <a:buNone/>
@@ -2963,12 +2963,12 @@
         </p:nvSpPr>
         <p:spPr>
           <a:xfrm>
-            <a:off x="612648" y="3547872"/>
-            <a:ext cx="3730752" cy="566928"/>
+            <a:off x="612648" y="3776472"/>
+            <a:ext cx="3730752" cy="612648"/>
           </a:xfrm>
           <a:prstGeom prst="roundRect">
             <a:avLst>
-              <a:gd name="adj" fmla="val 9677"/>
+              <a:gd name="adj" fmla="val 8955"/>
             </a:avLst>
           </a:prstGeom>
           <a:solidFill>
@@ -2997,7 +2997,7 @@
         </p:nvSpPr>
         <p:spPr>
           <a:xfrm>
-            <a:off x="740664" y="3671316"/>
+            <a:off x="740664" y="3922776"/>
             <a:ext cx="320040" cy="320040"/>
           </a:xfrm>
           <a:prstGeom prst="ellipse">
@@ -3042,8 +3042,8 @@
         </p:nvSpPr>
         <p:spPr>
           <a:xfrm>
-            <a:off x="1188720" y="3547872"/>
-            <a:ext cx="3063240" cy="566928"/>
+            <a:off x="1188720" y="3776472"/>
+            <a:ext cx="3063240" cy="612648"/>
           </a:xfrm>
           <a:prstGeom prst="rect">
             <a:avLst/>
@@ -3081,7 +3081,7 @@
                 <a:ea typeface="Arial" pitchFamily="34" charset="-122"/>
                 <a:cs typeface="Arial" pitchFamily="34" charset="-120"/>
               </a:rPr>
-              <a:t>   お～</a:t>
+              <a:t>   お〜</a:t>
             </a:r>
             <a:endParaRPr lang="en-US" sz="1100" dirty="0"/>
           </a:p>
@@ -3095,12 +3095,12 @@
         </p:nvSpPr>
         <p:spPr>
           <a:xfrm>
-            <a:off x="4800600" y="3547872"/>
-            <a:ext cx="3730752" cy="566928"/>
+            <a:off x="4800600" y="3776472"/>
+            <a:ext cx="3730752" cy="612648"/>
           </a:xfrm>
           <a:prstGeom prst="roundRect">
             <a:avLst>
-              <a:gd name="adj" fmla="val 9677"/>
+              <a:gd name="adj" fmla="val 8955"/>
             </a:avLst>
           </a:prstGeom>
           <a:solidFill>
@@ -3129,7 +3129,7 @@
         </p:nvSpPr>
         <p:spPr>
           <a:xfrm>
-            <a:off x="4928616" y="3671316"/>
+            <a:off x="4928616" y="3922776"/>
             <a:ext cx="320040" cy="320040"/>
           </a:xfrm>
           <a:prstGeom prst="ellipse">
@@ -3174,8 +3174,8 @@
         </p:nvSpPr>
         <p:spPr>
           <a:xfrm>
-            <a:off x="5376672" y="3547872"/>
-            <a:ext cx="3063240" cy="566928"/>
+            <a:off x="5376672" y="3776472"/>
+            <a:ext cx="3063240" cy="612648"/>
           </a:xfrm>
           <a:prstGeom prst="rect">
             <a:avLst/>
@@ -3413,7 +3413,7 @@
                 <a:ea typeface="Arial" pitchFamily="34" charset="-122"/>
                 <a:cs typeface="Arial" pitchFamily="34" charset="-120"/>
               </a:rPr>
-              <a:t>Coba tunjuk benda di sekitarmu pakai これ・それ・あれ!</a:t>
+              <a:t>Coba tunjuk benda di sekitarmu pakai kore, sore, are!</a:t>
             </a:r>
             <a:endParaRPr lang="en-US" sz="1400" dirty="0"/>
           </a:p>
@@ -3562,7 +3562,7 @@
                 <a:ea typeface="Arial" pitchFamily="34" charset="-122"/>
                 <a:cs typeface="Arial" pitchFamily="34" charset="-120"/>
               </a:rPr>
-              <a:t>これ・それ・あれ</a:t>
+              <a:t>Kore / Sore / Are</a:t>
             </a:r>
             <a:pPr indent="0" marL="0">
               <a:buNone/>
@@ -3590,7 +3590,7 @@
                 <a:ea typeface="Arial" pitchFamily="34" charset="-122"/>
                 <a:cs typeface="Arial" pitchFamily="34" charset="-120"/>
               </a:rPr>
-              <a:t>ini / itu</a:t>
+              <a:t>ini · itu · itu (jauh)</a:t>
             </a:r>
             <a:endParaRPr lang="en-US" sz="2300" dirty="0"/>
           </a:p>
@@ -3657,7 +3657,7 @@
             <a:r>
               <a:rPr lang="en-US" sz="2100" b="1" dirty="0">
                 <a:solidFill>
-                  <a:srgbClr val="D4912A"/>
+                  <a:srgbClr val="138A8A"/>
                 </a:solidFill>
                 <a:latin typeface="Arial" pitchFamily="34" charset="0"/>
                 <a:ea typeface="Arial" pitchFamily="34" charset="-122"/>
@@ -3677,7 +3677,7 @@
                 <a:ea typeface="Arial" pitchFamily="34" charset="-122"/>
                 <a:cs typeface="Arial" pitchFamily="34" charset="-120"/>
               </a:rPr>
-              <a:t>  /  </a:t>
+              <a:t> / </a:t>
             </a:r>
             <a:pPr algn="ctr" indent="0" marL="0">
               <a:buNone/>
@@ -3685,7 +3685,7 @@
             <a:r>
               <a:rPr lang="en-US" sz="2100" b="1" dirty="0">
                 <a:solidFill>
-                  <a:srgbClr val="D4912A"/>
+                  <a:srgbClr val="138A8A"/>
                 </a:solidFill>
                 <a:latin typeface="Arial" pitchFamily="34" charset="0"/>
                 <a:ea typeface="Arial" pitchFamily="34" charset="-122"/>
@@ -3705,7 +3705,7 @@
                 <a:ea typeface="Arial" pitchFamily="34" charset="-122"/>
                 <a:cs typeface="Arial" pitchFamily="34" charset="-120"/>
               </a:rPr>
-              <a:t>  /  </a:t>
+              <a:t> / </a:t>
             </a:r>
             <a:pPr algn="ctr" indent="0" marL="0">
               <a:buNone/>
@@ -3713,7 +3713,7 @@
             <a:r>
               <a:rPr lang="en-US" sz="2100" b="1" dirty="0">
                 <a:solidFill>
-                  <a:srgbClr val="D4912A"/>
+                  <a:srgbClr val="138A8A"/>
                 </a:solidFill>
                 <a:latin typeface="Arial" pitchFamily="34" charset="0"/>
                 <a:ea typeface="Arial" pitchFamily="34" charset="-122"/>
@@ -3761,7 +3761,7 @@
                 <a:ea typeface="Arial" pitchFamily="34" charset="-122"/>
                 <a:cs typeface="Arial" pitchFamily="34" charset="-120"/>
               </a:rPr>
-              <a:t>これ  = ini (dekat pembicara),  それ  = itu (dekat lawan bicara),  あれ  = itu (jauh dari keduanya). Ketiganya bisa berdiri sendiri seperti kata benda.</a:t>
+              <a:t>Tiga penunjuk benda:  これ  = ini (dekat aku),  それ  = itu (dekat kamu),  あれ  = itu (jauh dari kita). Ketiganya bisa berdiri sendiri seperti kata benda.</a:t>
             </a:r>
             <a:endParaRPr lang="en-US" sz="1200" dirty="0"/>
           </a:p>
@@ -4128,7 +4128,7 @@
                 <a:ea typeface="Arial" pitchFamily="34" charset="-122"/>
                 <a:cs typeface="Arial" pitchFamily="34" charset="-120"/>
               </a:rPr>
-              <a:t>この・その・あの</a:t>
+              <a:t>Kono / Sono / Ano + KB</a:t>
             </a:r>
             <a:pPr indent="0" marL="0">
               <a:buNone/>
@@ -4156,7 +4156,7 @@
                 <a:ea typeface="Arial" pitchFamily="34" charset="-122"/>
                 <a:cs typeface="Arial" pitchFamily="34" charset="-120"/>
               </a:rPr>
-              <a:t>+ kata benda</a:t>
+              <a:t>ditempel ke benda</a:t>
             </a:r>
             <a:endParaRPr lang="en-US" sz="2300" dirty="0"/>
           </a:p>
@@ -4223,7 +4223,7 @@
             <a:r>
               <a:rPr lang="en-US" sz="2100" b="1" dirty="0">
                 <a:solidFill>
-                  <a:srgbClr val="D4912A"/>
+                  <a:srgbClr val="138A8A"/>
                 </a:solidFill>
                 <a:latin typeface="Arial" pitchFamily="34" charset="0"/>
                 <a:ea typeface="Arial" pitchFamily="34" charset="-122"/>
@@ -4243,7 +4243,7 @@
                 <a:ea typeface="Arial" pitchFamily="34" charset="-122"/>
                 <a:cs typeface="Arial" pitchFamily="34" charset="-120"/>
               </a:rPr>
-              <a:t> + </a:t>
+              <a:t> +</a:t>
             </a:r>
             <a:pPr algn="ctr" indent="0" marL="0">
               <a:buNone/>
@@ -4271,7 +4271,7 @@
                 <a:ea typeface="Arial" pitchFamily="34" charset="-122"/>
                 <a:cs typeface="Arial" pitchFamily="34" charset="-120"/>
               </a:rPr>
-              <a:t> + </a:t>
+              <a:t>+ </a:t>
             </a:r>
             <a:pPr algn="ctr" indent="0" marL="0">
               <a:buNone/>
@@ -4327,7 +4327,7 @@
                 <a:ea typeface="Arial" pitchFamily="34" charset="-122"/>
                 <a:cs typeface="Arial" pitchFamily="34" charset="-120"/>
               </a:rPr>
-              <a:t>Berbeda dengan これ/それ/あれ,  この/その/あの  WAJIB ditempel di depan kata benda. Jadi  このほん  = buku ini.</a:t>
+              <a:t>この / その / あの  WAJIB ditempel di depan kata benda.  この  = ini,  その  = itu (dekatmu),  あの  = itu (jauh). Jadi  この ほん  = buku ini.</a:t>
             </a:r>
             <a:endParaRPr lang="en-US" sz="1200" dirty="0"/>
           </a:p>
@@ -4694,7 +4694,7 @@
                 <a:ea typeface="Arial" pitchFamily="34" charset="-122"/>
                 <a:cs typeface="Arial" pitchFamily="34" charset="-120"/>
               </a:rPr>
-              <a:t>Jawaban Ya / Bukan</a:t>
+              <a:t>Sou desu / Chigaimasu</a:t>
             </a:r>
             <a:pPr indent="0" marL="0">
               <a:buNone/>
@@ -4722,7 +4722,7 @@
                 <a:ea typeface="Arial" pitchFamily="34" charset="-122"/>
                 <a:cs typeface="Arial" pitchFamily="34" charset="-120"/>
               </a:rPr>
-              <a:t>そうです・ちがいます</a:t>
+              <a:t>jawaban ya / bukan</a:t>
             </a:r>
             <a:endParaRPr lang="en-US" sz="2300" dirty="0"/>
           </a:p>
@@ -4809,7 +4809,7 @@
                 <a:ea typeface="Arial" pitchFamily="34" charset="-122"/>
                 <a:cs typeface="Arial" pitchFamily="34" charset="-120"/>
               </a:rPr>
-              <a:t>  /  </a:t>
+              <a:t> / </a:t>
             </a:r>
             <a:pPr algn="ctr" indent="0" marL="0">
               <a:buNone/>
@@ -4817,7 +4817,7 @@
             <a:r>
               <a:rPr lang="en-US" sz="2100" b="1" dirty="0">
                 <a:solidFill>
-                  <a:srgbClr val="0E9F9A"/>
+                  <a:srgbClr val="2E9160"/>
                 </a:solidFill>
                 <a:latin typeface="Arial" pitchFamily="34" charset="0"/>
                 <a:ea typeface="Arial" pitchFamily="34" charset="-122"/>
@@ -4865,7 +4865,7 @@
                 <a:ea typeface="Arial" pitchFamily="34" charset="-122"/>
                 <a:cs typeface="Arial" pitchFamily="34" charset="-120"/>
               </a:rPr>
-              <a:t>Untuk menjawab "apakah ini X?". Kalau benar:  はい、そうです  (ya, betul). Kalau salah:  いいえ、ちがいます  (bukan).</a:t>
+              <a:t>Untuk menjawab "apakah ini X?". Kalau benar:  はい、そうです . Kalau salah:  いいえ、ちがいます .</a:t>
             </a:r>
             <a:endParaRPr lang="en-US" sz="1200" dirty="0"/>
           </a:p>
@@ -4977,7 +4977,7 @@
                 <a:ea typeface="Arial" pitchFamily="34" charset="-122"/>
                 <a:cs typeface="Arial" pitchFamily="34" charset="-120"/>
               </a:rPr>
-              <a:t>それはじしょですか。 はい、そうです。</a:t>
+              <a:t>はい、そうです。</a:t>
             </a:r>
             <a:endParaRPr lang="en-US" sz="1700" dirty="0"/>
           </a:p>
@@ -5016,7 +5016,7 @@
                 <a:ea typeface="Arial" pitchFamily="34" charset="-122"/>
                 <a:cs typeface="Arial" pitchFamily="34" charset="-120"/>
               </a:rPr>
-              <a:t>sore wa jisho desu ka. hai, sou desu</a:t>
+              <a:t>hai, sou desu</a:t>
             </a:r>
             <a:pPr indent="0" marL="0">
               <a:buNone/>
@@ -5044,7 +5044,7 @@
                 <a:ea typeface="Arial" pitchFamily="34" charset="-122"/>
                 <a:cs typeface="Arial" pitchFamily="34" charset="-120"/>
               </a:rPr>
-              <a:t>Apakah itu kamus? Ya, betul.</a:t>
+              <a:t>Ya, betul.</a:t>
             </a:r>
             <a:endParaRPr lang="en-US" sz="950" dirty="0"/>
           </a:p>
@@ -5232,7 +5232,7 @@
                 <a:ea typeface="Arial" pitchFamily="34" charset="-122"/>
                 <a:cs typeface="Arial" pitchFamily="34" charset="-120"/>
               </a:rPr>
-              <a:t>Kalimat Pilihan</a:t>
+              <a:t>~ka, ~ka</a:t>
             </a:r>
             <a:pPr indent="0" marL="0">
               <a:buNone/>
@@ -5260,7 +5260,7 @@
                 <a:ea typeface="Arial" pitchFamily="34" charset="-122"/>
                 <a:cs typeface="Arial" pitchFamily="34" charset="-120"/>
               </a:rPr>
-              <a:t>A atau B?</a:t>
+              <a:t>pilih A atau B</a:t>
             </a:r>
             <a:endParaRPr lang="en-US" sz="2300" dirty="0"/>
           </a:p>
@@ -5375,7 +5375,7 @@
                 <a:ea typeface="Arial" pitchFamily="34" charset="-122"/>
                 <a:cs typeface="Arial" pitchFamily="34" charset="-120"/>
               </a:rPr>
-              <a:t>です</a:t>
+              <a:t>ですか、</a:t>
             </a:r>
             <a:pPr algn="ctr" indent="0" marL="0">
               <a:buNone/>
@@ -5383,13 +5383,13 @@
             <a:r>
               <a:rPr lang="en-US" sz="2100" b="1" dirty="0">
                 <a:solidFill>
-                  <a:srgbClr val="EF4F4F"/>
-                </a:solidFill>
-                <a:latin typeface="Arial" pitchFamily="34" charset="0"/>
-                <a:ea typeface="Arial" pitchFamily="34" charset="-122"/>
-                <a:cs typeface="Arial" pitchFamily="34" charset="-120"/>
-              </a:rPr>
-              <a:t>か</a:t>
+                  <a:srgbClr val="94A3B8"/>
+                </a:solidFill>
+                <a:latin typeface="Arial" pitchFamily="34" charset="0"/>
+                <a:ea typeface="Arial" pitchFamily="34" charset="-122"/>
+                <a:cs typeface="Arial" pitchFamily="34" charset="-120"/>
+              </a:rPr>
+              <a:t> </a:t>
             </a:r>
             <a:pPr algn="ctr" indent="0" marL="0">
               <a:buNone/>
@@ -5397,13 +5397,41 @@
             <a:r>
               <a:rPr lang="en-US" sz="2100" b="1" dirty="0">
                 <a:solidFill>
+                  <a:srgbClr val="2F7FD6"/>
+                </a:solidFill>
+                <a:latin typeface="Arial" pitchFamily="34" charset="0"/>
+                <a:ea typeface="Arial" pitchFamily="34" charset="-122"/>
+                <a:cs typeface="Arial" pitchFamily="34" charset="-120"/>
+              </a:rPr>
+              <a:t>KB</a:t>
+            </a:r>
+            <a:pPr algn="ctr" indent="0" marL="0">
+              <a:buNone/>
+            </a:pPr>
+            <a:r>
+              <a:rPr lang="en-US" sz="2100" b="1" baseline="-40000" dirty="0">
+                <a:solidFill>
+                  <a:srgbClr val="2F7FD6"/>
+                </a:solidFill>
+                <a:latin typeface="Arial" pitchFamily="34" charset="0"/>
+                <a:ea typeface="Arial" pitchFamily="34" charset="-122"/>
+                <a:cs typeface="Arial" pitchFamily="34" charset="-120"/>
+              </a:rPr>
+              <a:t>2</a:t>
+            </a:r>
+            <a:pPr algn="ctr" indent="0" marL="0">
+              <a:buNone/>
+            </a:pPr>
+            <a:r>
+              <a:rPr lang="en-US" sz="2100" b="1" dirty="0">
+                <a:solidFill>
                   <a:srgbClr val="94A3B8"/>
                 </a:solidFill>
                 <a:latin typeface="Arial" pitchFamily="34" charset="0"/>
                 <a:ea typeface="Arial" pitchFamily="34" charset="-122"/>
                 <a:cs typeface="Arial" pitchFamily="34" charset="-120"/>
               </a:rPr>
-              <a:t>  、  </a:t>
+              <a:t> </a:t>
             </a:r>
             <a:pPr algn="ctr" indent="0" marL="0">
               <a:buNone/>
@@ -5411,69 +5439,13 @@
             <a:r>
               <a:rPr lang="en-US" sz="2100" b="1" dirty="0">
                 <a:solidFill>
-                  <a:srgbClr val="2F7FD6"/>
-                </a:solidFill>
-                <a:latin typeface="Arial" pitchFamily="34" charset="0"/>
-                <a:ea typeface="Arial" pitchFamily="34" charset="-122"/>
-                <a:cs typeface="Arial" pitchFamily="34" charset="-120"/>
-              </a:rPr>
-              <a:t>KB</a:t>
-            </a:r>
-            <a:pPr algn="ctr" indent="0" marL="0">
-              <a:buNone/>
-            </a:pPr>
-            <a:r>
-              <a:rPr lang="en-US" sz="2100" b="1" baseline="-40000" dirty="0">
-                <a:solidFill>
-                  <a:srgbClr val="2F7FD6"/>
-                </a:solidFill>
-                <a:latin typeface="Arial" pitchFamily="34" charset="0"/>
-                <a:ea typeface="Arial" pitchFamily="34" charset="-122"/>
-                <a:cs typeface="Arial" pitchFamily="34" charset="-120"/>
-              </a:rPr>
-              <a:t>2</a:t>
-            </a:r>
-            <a:pPr algn="ctr" indent="0" marL="0">
-              <a:buNone/>
-            </a:pPr>
-            <a:r>
-              <a:rPr lang="en-US" sz="2100" b="1" dirty="0">
-                <a:solidFill>
-                  <a:srgbClr val="94A3B8"/>
-                </a:solidFill>
-                <a:latin typeface="Arial" pitchFamily="34" charset="0"/>
-                <a:ea typeface="Arial" pitchFamily="34" charset="-122"/>
-                <a:cs typeface="Arial" pitchFamily="34" charset="-120"/>
-              </a:rPr>
-              <a:t> </a:t>
-            </a:r>
-            <a:pPr algn="ctr" indent="0" marL="0">
-              <a:buNone/>
-            </a:pPr>
-            <a:r>
-              <a:rPr lang="en-US" sz="2100" b="1" dirty="0">
-                <a:solidFill>
                   <a:srgbClr val="8B5CF6"/>
                 </a:solidFill>
                 <a:latin typeface="Arial" pitchFamily="34" charset="0"/>
                 <a:ea typeface="Arial" pitchFamily="34" charset="-122"/>
                 <a:cs typeface="Arial" pitchFamily="34" charset="-120"/>
               </a:rPr>
-              <a:t>です</a:t>
-            </a:r>
-            <a:pPr algn="ctr" indent="0" marL="0">
-              <a:buNone/>
-            </a:pPr>
-            <a:r>
-              <a:rPr lang="en-US" sz="2100" b="1" dirty="0">
-                <a:solidFill>
-                  <a:srgbClr val="EF4F4F"/>
-                </a:solidFill>
-                <a:latin typeface="Arial" pitchFamily="34" charset="0"/>
-                <a:ea typeface="Arial" pitchFamily="34" charset="-122"/>
-                <a:cs typeface="Arial" pitchFamily="34" charset="-120"/>
-              </a:rPr>
-              <a:t>か</a:t>
+              <a:t>ですか</a:t>
             </a:r>
             <a:endParaRPr lang="en-US" sz="2100" dirty="0"/>
           </a:p>
@@ -5515,7 +5487,7 @@
                 <a:ea typeface="Arial" pitchFamily="34" charset="-122"/>
                 <a:cs typeface="Arial" pitchFamily="34" charset="-120"/>
               </a:rPr>
-              <a:t>Sebut dua pilihan, masing-masing diakhiri  か . Jawabnya tidak pakai  はい/いいえ , tapi langsung sebut pilihan yang benar.</a:t>
+              <a:t>Untuk nanya "A atau B?". Sebut dua pilihan, masing-masing diakhiri  か . Jawabnya langsung sebut yang benar, tanpa  はい / いいえ .</a:t>
             </a:r>
             <a:endParaRPr lang="en-US" sz="1200" dirty="0"/>
           </a:p>
@@ -5882,7 +5854,7 @@
                 <a:ea typeface="Arial" pitchFamily="34" charset="-122"/>
                 <a:cs typeface="Arial" pitchFamily="34" charset="-120"/>
               </a:rPr>
-              <a:t>Partikel  の</a:t>
+              <a:t>KB no KB</a:t>
             </a:r>
             <a:pPr indent="0" marL="0">
               <a:buNone/>
@@ -6109,7 +6081,7 @@
                 <a:ea typeface="Arial" pitchFamily="34" charset="-122"/>
                 <a:cs typeface="Arial" pitchFamily="34" charset="-120"/>
               </a:rPr>
-              <a:t>の  menyambung dua kata benda: KB1 bisa jenis/topik dari KB2 ( コンピューターのほん  = buku tentang komputer), atau pemiliknya ( わたしの  = punya saya).</a:t>
+              <a:t>の  = lem penyambung dua benda. Bisa berarti jenis/topik ( コンピューターの ほん  = buku tentang komputer) atau pemilik ( わたしの  = punya saya).</a:t>
             </a:r>
             <a:endParaRPr lang="en-US" sz="1200" dirty="0"/>
           </a:p>
@@ -6476,7 +6448,7 @@
                 <a:ea typeface="Arial" pitchFamily="34" charset="-122"/>
                 <a:cs typeface="Arial" pitchFamily="34" charset="-120"/>
               </a:rPr>
-              <a:t>の  Pengganti Benda</a:t>
+              <a:t>No pengganti KB</a:t>
             </a:r>
             <a:pPr indent="0" marL="0">
               <a:buNone/>
@@ -6504,7 +6476,7 @@
                 <a:ea typeface="Arial" pitchFamily="34" charset="-122"/>
                 <a:cs typeface="Arial" pitchFamily="34" charset="-120"/>
               </a:rPr>
-              <a:t>tanpa KB kedua</a:t>
+              <a:t>hindari pengulangan</a:t>
             </a:r>
             <a:endParaRPr lang="en-US" sz="2300" dirty="0"/>
           </a:p>
@@ -6661,7 +6633,7 @@
                 <a:ea typeface="Arial" pitchFamily="34" charset="-122"/>
                 <a:cs typeface="Arial" pitchFamily="34" charset="-120"/>
               </a:rPr>
-              <a:t>Kalau bendanya sudah jelas dari obrolan, KB2 boleh dihilangkan — cukup  の  saja, biar tak perlu mengulang kata yang sama.</a:t>
+              <a:t>Kalau bendanya sudah jelas dari obrolan, kata benda di belakang boleh dihilangkan — cukup  の  saja.</a:t>
             </a:r>
             <a:endParaRPr lang="en-US" sz="1200" dirty="0"/>
           </a:p>
@@ -7028,7 +7000,7 @@
                 <a:ea typeface="Arial" pitchFamily="34" charset="-122"/>
                 <a:cs typeface="Arial" pitchFamily="34" charset="-120"/>
               </a:rPr>
-              <a:t>Awalan  お</a:t>
+              <a:t>O~ (awalan sopan)</a:t>
             </a:r>
             <a:pPr indent="0" marL="0">
               <a:buNone/>
@@ -7056,7 +7028,7 @@
                 <a:ea typeface="Arial" pitchFamily="34" charset="-122"/>
                 <a:cs typeface="Arial" pitchFamily="34" charset="-120"/>
               </a:rPr>
-              <a:t>awalan sopan</a:t>
+              <a:t>lebih halus</a:t>
             </a:r>
             <a:endParaRPr lang="en-US" sz="2300" dirty="0"/>
           </a:p>
@@ -7151,20 +7123,6 @@
             <a:r>
               <a:rPr lang="en-US" sz="2100" b="1" dirty="0">
                 <a:solidFill>
-                  <a:srgbClr val="94A3B8"/>
-                </a:solidFill>
-                <a:latin typeface="Arial" pitchFamily="34" charset="0"/>
-                <a:ea typeface="Arial" pitchFamily="34" charset="-122"/>
-                <a:cs typeface="Arial" pitchFamily="34" charset="-120"/>
-              </a:rPr>
-              <a:t> </a:t>
-            </a:r>
-            <a:pPr algn="ctr" indent="0" marL="0">
-              <a:buNone/>
-            </a:pPr>
-            <a:r>
-              <a:rPr lang="en-US" sz="2100" b="1" dirty="0">
-                <a:solidFill>
                   <a:srgbClr val="2F7FD6"/>
                 </a:solidFill>
                 <a:latin typeface="Arial" pitchFamily="34" charset="0"/>
@@ -7213,7 +7171,7 @@
                 <a:ea typeface="Arial" pitchFamily="34" charset="-122"/>
                 <a:cs typeface="Arial" pitchFamily="34" charset="-120"/>
               </a:rPr>
-              <a:t>お  ditempel di depan beberapa kata benda agar terdengar lebih sopan/halus.</a:t>
+              <a:t>お  ditempel di depan beberapa kata benda biar lebih sopan. Contoh:  なまえ → おなまえ ,  さけ → おさけ ,</a:t>
             </a:r>
             <a:endParaRPr lang="en-US" sz="1200" dirty="0"/>
           </a:p>
@@ -7233,7 +7191,7 @@
                 <a:ea typeface="Arial" pitchFamily="34" charset="-122"/>
                 <a:cs typeface="Arial" pitchFamily="34" charset="-120"/>
               </a:rPr>
-              <a:t>Contoh:  なまえ → おなまえ ,  さけ → おさけ ,  みやげ → おみやげ .</a:t>
+              <a:t>みやげ → おみやげ .</a:t>
             </a:r>
             <a:endParaRPr lang="en-US" sz="1200" dirty="0"/>
           </a:p>
@@ -7600,7 +7558,7 @@
                 <a:ea typeface="Arial" pitchFamily="34" charset="-122"/>
                 <a:cs typeface="Arial" pitchFamily="34" charset="-120"/>
               </a:rPr>
-              <a:t>そうですか</a:t>
+              <a:t>Sou desu ka</a:t>
             </a:r>
             <a:pPr indent="0" marL="0">
               <a:buNone/>
@@ -7695,41 +7653,13 @@
             <a:r>
               <a:rPr lang="en-US" sz="2100" b="1" dirty="0">
                 <a:solidFill>
-                  <a:srgbClr val="D4912A"/>
-                </a:solidFill>
-                <a:latin typeface="Arial" pitchFamily="34" charset="0"/>
-                <a:ea typeface="Arial" pitchFamily="34" charset="-122"/>
-                <a:cs typeface="Arial" pitchFamily="34" charset="-120"/>
-              </a:rPr>
-              <a:t>そう</a:t>
-            </a:r>
-            <a:pPr algn="ctr" indent="0" marL="0">
-              <a:buNone/>
-            </a:pPr>
-            <a:r>
-              <a:rPr lang="en-US" sz="2100" b="1" dirty="0">
-                <a:solidFill>
                   <a:srgbClr val="8B5CF6"/>
                 </a:solidFill>
                 <a:latin typeface="Arial" pitchFamily="34" charset="0"/>
                 <a:ea typeface="Arial" pitchFamily="34" charset="-122"/>
                 <a:cs typeface="Arial" pitchFamily="34" charset="-120"/>
               </a:rPr>
-              <a:t>です</a:t>
-            </a:r>
-            <a:pPr algn="ctr" indent="0" marL="0">
-              <a:buNone/>
-            </a:pPr>
-            <a:r>
-              <a:rPr lang="en-US" sz="2100" b="1" dirty="0">
-                <a:solidFill>
-                  <a:srgbClr val="EF4F4F"/>
-                </a:solidFill>
-                <a:latin typeface="Arial" pitchFamily="34" charset="0"/>
-                <a:ea typeface="Arial" pitchFamily="34" charset="-122"/>
-                <a:cs typeface="Arial" pitchFamily="34" charset="-120"/>
-              </a:rPr>
-              <a:t>か</a:t>
+              <a:t>そうですか</a:t>
             </a:r>
             <a:endParaRPr lang="en-US" sz="2100" dirty="0"/>
           </a:p>
@@ -7771,7 +7701,7 @@
                 <a:ea typeface="Arial" pitchFamily="34" charset="-122"/>
                 <a:cs typeface="Arial" pitchFamily="34" charset="-120"/>
               </a:rPr>
-              <a:t>Ungkapan saat menerima info baru: "Oh, begitu." Nada TURUN di akhir — beda dengan  そうですか？  untuk bertanya (nada naik).</a:t>
+              <a:t>Ungkapan saat dapat info baru: "Oh, begitu". Nada TURUN di akhir. (Kalau naik, jadi pertanyaan  そうですか ?)</a:t>
             </a:r>
             <a:endParaRPr lang="en-US" sz="1200" dirty="0"/>
           </a:p>
@@ -7883,7 +7813,7 @@
                 <a:ea typeface="Arial" pitchFamily="34" charset="-122"/>
                 <a:cs typeface="Arial" pitchFamily="34" charset="-120"/>
               </a:rPr>
-              <a:t>このかさはシティさんのです。 そうですか。</a:t>
+              <a:t>そうですか。</a:t>
             </a:r>
             <a:endParaRPr lang="en-US" sz="1700" dirty="0"/>
           </a:p>
@@ -7922,7 +7852,7 @@
                 <a:ea typeface="Arial" pitchFamily="34" charset="-122"/>
                 <a:cs typeface="Arial" pitchFamily="34" charset="-120"/>
               </a:rPr>
-              <a:t>kono kasa wa Siti-san no desu. sou desu ka</a:t>
+              <a:t>sou desu ka</a:t>
             </a:r>
             <a:pPr indent="0" marL="0">
               <a:buNone/>
@@ -7950,7 +7880,7 @@
                 <a:ea typeface="Arial" pitchFamily="34" charset="-122"/>
                 <a:cs typeface="Arial" pitchFamily="34" charset="-120"/>
               </a:rPr>
-              <a:t>Payung ini punya Siti. Oh, begitu.</a:t>
+              <a:t>Oh, begitu.</a:t>
             </a:r>
             <a:endParaRPr lang="en-US" sz="950" dirty="0"/>
           </a:p>

</xml_diff>